<commit_message>
Houdini-presentasjon v3: SODAI-referanse FFK concept store med bilder fra sodai.no
Co-Authored-By: Claude Opus 5.5 <noreply@anthropic.com>
Claude-Session: https://claude.ai/code/session_0123qFace2keco5b7aaKtCRy
</commit_message>
<xml_diff>
--- a/analyser/houdini/Houdini_i_Norge.pptx
+++ b/analyser/houdini/Houdini_i_Norge.pptx
@@ -20,6 +20,7 @@
     <p:sldId id="268" r:id="rId19"/>
     <p:sldId id="269" r:id="rId20"/>
     <p:sldId id="270" r:id="rId21"/>
+    <p:sldId id="271" r:id="rId22"/>
   </p:sldIdLst>
   <p:sldSz cx="12191695" cy="6858000" type="screen4x3"/>
   <p:notesSz cx="6858000" cy="9144000"/>
@@ -7406,6 +7407,356 @@
 </file>
 
 <file path=ppt/slides/slide15.xml><?xml version="1.0" encoding="utf-8"?>
+<p:sld xmlns:a="http://schemas.openxmlformats.org/drawingml/2006/main" xmlns:p="http://schemas.openxmlformats.org/presentationml/2006/main" xmlns:r="http://schemas.openxmlformats.org/officeDocument/2006/relationships">
+  <p:cSld>
+    <p:bg>
+      <p:bgPr>
+        <a:solidFill>
+          <a:srgbClr val="FFFFFF"/>
+        </a:solidFill>
+        <a:effectLst/>
+      </p:bgPr>
+    </p:bg>
+    <p:spTree>
+      <p:nvGrpSpPr>
+        <p:cNvPr id="1" name=""/>
+        <p:cNvGrpSpPr/>
+        <p:nvPr/>
+      </p:nvGrpSpPr>
+      <p:grpSpPr/>
+      <p:sp>
+        <p:nvSpPr>
+          <p:cNvPr id="2" name="TextBox 1"/>
+          <p:cNvSpPr txBox="1"/>
+          <p:nvPr/>
+        </p:nvSpPr>
+        <p:spPr>
+          <a:xfrm>
+            <a:off x="457200" y="347472"/>
+            <a:ext cx="5486400" cy="274320"/>
+          </a:xfrm>
+          <a:prstGeom prst="rect">
+            <a:avLst/>
+          </a:prstGeom>
+          <a:noFill/>
+        </p:spPr>
+        <p:txBody>
+          <a:bodyPr wrap="square" anchor="t" lIns="0" rIns="0" tIns="0" bIns="0">
+            <a:spAutoFit/>
+          </a:bodyPr>
+          <a:lstStyle/>
+          <a:p>
+            <a:pPr algn="l">
+              <a:spcAft>
+                <a:spcPts val="600"/>
+              </a:spcAft>
+            </a:pPr>
+            <a:r>
+              <a:rPr sz="1100" b="1">
+                <a:solidFill>
+                  <a:srgbClr val="8A8A86"/>
+                </a:solidFill>
+                <a:latin typeface="Inter"/>
+              </a:rPr>
+              <a:t>REFERANSE</a:t>
+            </a:r>
+          </a:p>
+        </p:txBody>
+      </p:sp>
+      <p:sp>
+        <p:nvSpPr>
+          <p:cNvPr id="3" name="TextBox 2"/>
+          <p:cNvSpPr txBox="1"/>
+          <p:nvPr/>
+        </p:nvSpPr>
+        <p:spPr>
+          <a:xfrm>
+            <a:off x="6248095" y="347472"/>
+            <a:ext cx="5486400" cy="274320"/>
+          </a:xfrm>
+          <a:prstGeom prst="rect">
+            <a:avLst/>
+          </a:prstGeom>
+          <a:noFill/>
+        </p:spPr>
+        <p:txBody>
+          <a:bodyPr wrap="square" anchor="t" lIns="0" rIns="0" tIns="0" bIns="0">
+            <a:spAutoFit/>
+          </a:bodyPr>
+          <a:lstStyle/>
+          <a:p>
+            <a:pPr algn="r">
+              <a:spcAft>
+                <a:spcPts val="600"/>
+              </a:spcAft>
+            </a:pPr>
+            <a:r>
+              <a:rPr sz="900" b="0">
+                <a:solidFill>
+                  <a:srgbClr val="8A8A86"/>
+                </a:solidFill>
+                <a:latin typeface="Inter"/>
+              </a:rPr>
+              <a:t>Forslag til Houdini Sportswear  ·  Bent Finset / SODAI</a:t>
+            </a:r>
+          </a:p>
+        </p:txBody>
+      </p:sp>
+      <p:sp>
+        <p:nvSpPr>
+          <p:cNvPr id="4" name="TextBox 3"/>
+          <p:cNvSpPr txBox="1"/>
+          <p:nvPr/>
+        </p:nvSpPr>
+        <p:spPr>
+          <a:xfrm>
+            <a:off x="457200" y="621792"/>
+            <a:ext cx="11277295" cy="914400"/>
+          </a:xfrm>
+          <a:prstGeom prst="rect">
+            <a:avLst/>
+          </a:prstGeom>
+          <a:noFill/>
+        </p:spPr>
+        <p:txBody>
+          <a:bodyPr wrap="square" anchor="t" lIns="0" rIns="0" tIns="0" bIns="0">
+            <a:spAutoFit/>
+          </a:bodyPr>
+          <a:lstStyle/>
+          <a:p>
+            <a:pPr algn="l">
+              <a:spcAft>
+                <a:spcPts val="600"/>
+              </a:spcAft>
+            </a:pPr>
+            <a:r>
+              <a:rPr sz="2800" b="1">
+                <a:solidFill>
+                  <a:srgbClr val="0F0F0F"/>
+                </a:solidFill>
+                <a:latin typeface="Inter"/>
+              </a:rPr>
+              <a:t>SODAI har levert en skreddersydd merkevarebutikk før: FFK concept store i Fredrikstad, 2025</a:t>
+            </a:r>
+          </a:p>
+        </p:txBody>
+      </p:sp>
+      <p:pic>
+        <p:nvPicPr>
+          <p:cNvPr id="5" name="Picture 4" descr="ffk_hero_c7135063x3959352.jpg"/>
+          <p:cNvPicPr>
+            <a:picLocks noChangeAspect="1"/>
+          </p:cNvPicPr>
+          <p:nvPr/>
+        </p:nvPicPr>
+        <p:blipFill>
+          <a:blip r:embed="rId2"/>
+          <a:stretch>
+            <a:fillRect/>
+          </a:stretch>
+        </p:blipFill>
+        <p:spPr>
+          <a:xfrm>
+            <a:off x="457200" y="1691640"/>
+            <a:ext cx="7135063" cy="3959352"/>
+          </a:xfrm>
+          <a:prstGeom prst="rect">
+            <a:avLst/>
+          </a:prstGeom>
+        </p:spPr>
+      </p:pic>
+      <p:pic>
+        <p:nvPicPr>
+          <p:cNvPr id="6" name="Picture 5" descr="ffk_3_c1x1.jpg"/>
+          <p:cNvPicPr>
+            <a:picLocks noChangeAspect="1"/>
+          </p:cNvPicPr>
+          <p:nvPr/>
+        </p:nvPicPr>
+        <p:blipFill>
+          <a:blip r:embed="rId3"/>
+          <a:stretch>
+            <a:fillRect/>
+          </a:stretch>
+        </p:blipFill>
+        <p:spPr>
+          <a:xfrm>
+            <a:off x="7775143" y="1691640"/>
+            <a:ext cx="1888236" cy="1888236"/>
+          </a:xfrm>
+          <a:prstGeom prst="rect">
+            <a:avLst/>
+          </a:prstGeom>
+        </p:spPr>
+      </p:pic>
+      <p:pic>
+        <p:nvPicPr>
+          <p:cNvPr id="7" name="Picture 6" descr="ffk_2_c1x1.jpg"/>
+          <p:cNvPicPr>
+            <a:picLocks noChangeAspect="1"/>
+          </p:cNvPicPr>
+          <p:nvPr/>
+        </p:nvPicPr>
+        <p:blipFill>
+          <a:blip r:embed="rId4"/>
+          <a:stretch>
+            <a:fillRect/>
+          </a:stretch>
+        </p:blipFill>
+        <p:spPr>
+          <a:xfrm>
+            <a:off x="9846259" y="1691640"/>
+            <a:ext cx="1888236" cy="1888236"/>
+          </a:xfrm>
+          <a:prstGeom prst="rect">
+            <a:avLst/>
+          </a:prstGeom>
+        </p:spPr>
+      </p:pic>
+      <p:pic>
+        <p:nvPicPr>
+          <p:cNvPr id="8" name="Picture 7" descr="ffk_0_c1x1.jpg"/>
+          <p:cNvPicPr>
+            <a:picLocks noChangeAspect="1"/>
+          </p:cNvPicPr>
+          <p:nvPr/>
+        </p:nvPicPr>
+        <p:blipFill>
+          <a:blip r:embed="rId5"/>
+          <a:stretch>
+            <a:fillRect/>
+          </a:stretch>
+        </p:blipFill>
+        <p:spPr>
+          <a:xfrm>
+            <a:off x="7775143" y="3762756"/>
+            <a:ext cx="1888236" cy="1888236"/>
+          </a:xfrm>
+          <a:prstGeom prst="rect">
+            <a:avLst/>
+          </a:prstGeom>
+        </p:spPr>
+      </p:pic>
+      <p:pic>
+        <p:nvPicPr>
+          <p:cNvPr id="9" name="Picture 8" descr="ffk_7_c1x1.jpg"/>
+          <p:cNvPicPr>
+            <a:picLocks noChangeAspect="1"/>
+          </p:cNvPicPr>
+          <p:nvPr/>
+        </p:nvPicPr>
+        <p:blipFill>
+          <a:blip r:embed="rId6"/>
+          <a:stretch>
+            <a:fillRect/>
+          </a:stretch>
+        </p:blipFill>
+        <p:spPr>
+          <a:xfrm>
+            <a:off x="9846259" y="3762756"/>
+            <a:ext cx="1888236" cy="1888236"/>
+          </a:xfrm>
+          <a:prstGeom prst="rect">
+            <a:avLst/>
+          </a:prstGeom>
+        </p:spPr>
+      </p:pic>
+      <p:sp>
+        <p:nvSpPr>
+          <p:cNvPr id="10" name="TextBox 9"/>
+          <p:cNvSpPr txBox="1"/>
+          <p:nvPr/>
+        </p:nvSpPr>
+        <p:spPr>
+          <a:xfrm>
+            <a:off x="457200" y="5788152"/>
+            <a:ext cx="11277295" cy="548640"/>
+          </a:xfrm>
+          <a:prstGeom prst="rect">
+            <a:avLst/>
+          </a:prstGeom>
+          <a:noFill/>
+        </p:spPr>
+        <p:txBody>
+          <a:bodyPr wrap="square" anchor="t" lIns="0" rIns="0" tIns="0" bIns="0">
+            <a:spAutoFit/>
+          </a:bodyPr>
+          <a:lstStyle/>
+          <a:p>
+            <a:pPr algn="l">
+              <a:spcAft>
+                <a:spcPts val="600"/>
+              </a:spcAft>
+            </a:pPr>
+            <a:r>
+              <a:rPr sz="1400" b="1">
+                <a:solidFill>
+                  <a:srgbClr val="0F0F0F"/>
+                </a:solidFill>
+                <a:latin typeface="Inter"/>
+              </a:rPr>
+              <a:t>Levert: </a:t>
+            </a:r>
+            <a:r>
+              <a:rPr sz="1400" b="0">
+                <a:solidFill>
+                  <a:srgbClr val="0F0F0F"/>
+                </a:solidFill>
+                <a:latin typeface="Inter"/>
+              </a:rPr>
+              <a:t>garderober, utstillingshyller, kassadisk med lampe, speil, podium og bordet «Plankehaugen». Alt skreddersydd for klubbens egen butikk: lyssatte hyller, sorte draktnisjer og stablet heltre.</a:t>
+            </a:r>
+          </a:p>
+        </p:txBody>
+      </p:sp>
+      <p:sp>
+        <p:nvSpPr>
+          <p:cNvPr id="11" name="TextBox 10"/>
+          <p:cNvSpPr txBox="1"/>
+          <p:nvPr/>
+        </p:nvSpPr>
+        <p:spPr>
+          <a:xfrm>
+            <a:off x="457200" y="6291072"/>
+            <a:ext cx="11277295" cy="411480"/>
+          </a:xfrm>
+          <a:prstGeom prst="rect">
+            <a:avLst/>
+          </a:prstGeom>
+          <a:noFill/>
+        </p:spPr>
+        <p:txBody>
+          <a:bodyPr wrap="square" anchor="b" lIns="0" rIns="0" tIns="0" bIns="0">
+            <a:spAutoFit/>
+          </a:bodyPr>
+          <a:lstStyle/>
+          <a:p>
+            <a:pPr algn="l">
+              <a:spcAft>
+                <a:spcPts val="600"/>
+              </a:spcAft>
+            </a:pPr>
+            <a:r>
+              <a:rPr sz="900" b="0">
+                <a:solidFill>
+                  <a:srgbClr val="8A8A86"/>
+                </a:solidFill>
+                <a:latin typeface="Inter"/>
+              </a:rPr>
+              <a:t>Kunde: Fredrikstad Fotballklubb (FFK). Bilder og leveranse: sodai.no/prosjekter/ffk-concept-store (hentet 24.10.2026).</a:t>
+            </a:r>
+          </a:p>
+        </p:txBody>
+      </p:sp>
+    </p:spTree>
+  </p:cSld>
+  <p:clrMapOvr>
+    <a:masterClrMapping/>
+  </p:clrMapOvr>
+</p:sld>
+</file>
+
+<file path=ppt/slides/slide16.xml><?xml version="1.0" encoding="utf-8"?>
 <p:sld xmlns:a="http://schemas.openxmlformats.org/drawingml/2006/main" xmlns:p="http://schemas.openxmlformats.org/presentationml/2006/main" xmlns:r="http://schemas.openxmlformats.org/officeDocument/2006/relationships">
   <p:cSld>
     <p:bg>

</xml_diff>